<commit_message>
Marca Autoescola Renascer com logo oficial
</commit_message>
<xml_diff>
--- a/docs/Apresentacao-Interativa-ABCDETRAN.pptx
+++ b/docs/Apresentacao-Interativa-ABCDETRAN.pptx
@@ -3174,7 +3174,7 @@
                   <a:srgbClr val="FFFFFF"/>
                 </a:solidFill>
               </a:rPr>
-              <a:t>Auto Escola — Simulados ABCDETRAN: passo a passo interativo para navegar na prova teórica</a:t>
+              <a:t>Autoescola Renascer — Simulados ABCDETRAN: passo a passo interativo para navegar na prova teórica</a:t>
             </a:r>
           </a:p>
         </p:txBody>
@@ -4908,7 +4908,7 @@
                   <a:srgbClr val="F5B301"/>
                 </a:solidFill>
               </a:rPr>
-              <a:t>Apresentação interativa — use os botões para navegar e refazer o quiz.</a:t>
+              <a:t>Autoescola Renascer — (85) 99615-6124 · @autoescola_renascer</a:t>
             </a:r>
           </a:p>
         </p:txBody>

</xml_diff>